<commit_message>
modified:   Esther_01.pptx modified:   Esther_02.pptx
</commit_message>
<xml_diff>
--- a/ppt/Esther/Esther_02.pptx
+++ b/ppt/Esther/Esther_02.pptx
@@ -3943,9 +3943,6 @@
             </a:br>
             <a:r>
               <a:rPr lang="zh-CN" altLang="en-US" sz="4800" b="1" dirty="0">
-                <a:solidFill>
-                  <a:srgbClr val="FFC000"/>
-                </a:solidFill>
                 <a:latin typeface="DFKai-SB" panose="03000509000000000000" pitchFamily="65" charset="-120"/>
                 <a:ea typeface="DFKai-SB" panose="03000509000000000000" pitchFamily="65" charset="-120"/>
                 <a:sym typeface="+mn-ea"/>
@@ -4072,7 +4069,7 @@
                 <a:latin typeface="DFKai-SB" panose="03000509000000000000" pitchFamily="65" charset="-120"/>
                 <a:ea typeface="DFKai-SB" panose="03000509000000000000" pitchFamily="65" charset="-120"/>
               </a:rPr>
-              <a:t>08-01-2025</a:t>
+              <a:t>08-01-2026</a:t>
             </a:r>
           </a:p>
         </p:txBody>
@@ -4420,7 +4417,7 @@
             <a:pPr algn="ctr"/>
             <a:r>
               <a:rPr lang="en-US" sz="4000" dirty="0"/>
-              <a:t>of God</a:t>
+              <a:t>of the God</a:t>
             </a:r>
           </a:p>
         </p:txBody>
@@ -4914,33 +4911,6 @@
           </a:p>
         </p:txBody>
       </p:sp>
-      <p:pic>
-        <p:nvPicPr>
-          <p:cNvPr id="7" name="Content Placeholder 6" descr="Screenshot 2025-07-31 213648"/>
-          <p:cNvPicPr>
-            <a:picLocks noGrp="1" noChangeAspect="1"/>
-          </p:cNvPicPr>
-          <p:nvPr>
-            <p:ph sz="half" idx="2"/>
-          </p:nvPr>
-        </p:nvPicPr>
-        <p:blipFill>
-          <a:blip r:embed="rId2"/>
-          <a:srcRect r="15739" b="9740"/>
-          <a:stretch>
-            <a:fillRect/>
-          </a:stretch>
-        </p:blipFill>
-        <p:spPr>
-          <a:xfrm>
-            <a:off x="6443980" y="633095"/>
-            <a:ext cx="5289550" cy="3101975"/>
-          </a:xfrm>
-          <a:prstGeom prst="rect">
-            <a:avLst/>
-          </a:prstGeom>
-        </p:spPr>
-      </p:pic>
       <p:sp>
         <p:nvSpPr>
           <p:cNvPr id="6" name="Text Box 5"/>
@@ -4949,8 +4919,8 @@
         </p:nvSpPr>
         <p:spPr>
           <a:xfrm>
-            <a:off x="458470" y="2784108"/>
-            <a:ext cx="5203191" cy="2308324"/>
+            <a:off x="609600" y="931862"/>
+            <a:ext cx="9635099" cy="5632311"/>
           </a:xfrm>
           <a:prstGeom prst="rect">
             <a:avLst/>
@@ -4970,7 +4940,7 @@
               <a:rPr lang="en-US" altLang="en-US" sz="2400" dirty="0">
                 <a:sym typeface="+mn-ea"/>
               </a:rPr>
-              <a:t>1.No Turning Back</a:t>
+              <a:t>1. A song for Children: It's Purim!</a:t>
             </a:r>
           </a:p>
           <a:p>
@@ -4979,70 +4949,16 @@
             </a:pPr>
             <a:r>
               <a:rPr lang="en-US" altLang="en-US" sz="2400" dirty="0">
-                <a:solidFill>
-                  <a:srgbClr val="FF0000"/>
-                </a:solidFill>
                 <a:sym typeface="+mn-ea"/>
-                <a:hlinkClick r:id="rId3"/>
+                <a:hlinkClick r:id="rId2">
+                  <a:extLst>
+                    <a:ext uri="{A12FA001-AC4F-418D-AE19-62706E023703}">
+                      <ahyp:hlinkClr xmlns:ahyp="http://schemas.microsoft.com/office/drawing/2018/hyperlinkcolor" val="tx"/>
+                    </a:ext>
+                  </a:extLst>
+                </a:hlinkClick>
               </a:rPr>
-              <a:t>https://</a:t>
-            </a:r>
-            <a:r>
-              <a:rPr lang="en-US" altLang="en-US" sz="2400" dirty="0" err="1">
-                <a:solidFill>
-                  <a:srgbClr val="FF0000"/>
-                </a:solidFill>
-                <a:sym typeface="+mn-ea"/>
-                <a:hlinkClick r:id="rId3"/>
-              </a:rPr>
-              <a:t>www.youtube.com</a:t>
-            </a:r>
-            <a:r>
-              <a:rPr lang="en-US" altLang="en-US" sz="2400" dirty="0">
-                <a:solidFill>
-                  <a:srgbClr val="FF0000"/>
-                </a:solidFill>
-                <a:sym typeface="+mn-ea"/>
-                <a:hlinkClick r:id="rId3"/>
-              </a:rPr>
-              <a:t>/</a:t>
-            </a:r>
-            <a:r>
-              <a:rPr lang="en-US" altLang="en-US" sz="2400" dirty="0" err="1">
-                <a:solidFill>
-                  <a:srgbClr val="FF0000"/>
-                </a:solidFill>
-                <a:sym typeface="+mn-ea"/>
-                <a:hlinkClick r:id="rId3"/>
-              </a:rPr>
-              <a:t>watch?v</a:t>
-            </a:r>
-            <a:r>
-              <a:rPr lang="en-US" altLang="en-US" sz="2400" dirty="0">
-                <a:solidFill>
-                  <a:srgbClr val="FF0000"/>
-                </a:solidFill>
-                <a:sym typeface="+mn-ea"/>
-                <a:hlinkClick r:id="rId3"/>
-              </a:rPr>
-              <a:t>=yNtid3wdDWA&amp;list=RDyNtid3wdDWA&amp;start_radio=1&amp;ab_channel=</a:t>
-            </a:r>
-            <a:r>
-              <a:rPr lang="en-US" altLang="en-US" sz="2400" dirty="0" err="1">
-                <a:solidFill>
-                  <a:srgbClr val="FF0000"/>
-                </a:solidFill>
-                <a:sym typeface="+mn-ea"/>
-                <a:hlinkClick r:id="rId3"/>
-              </a:rPr>
-              <a:t>GaiseBaba</a:t>
-            </a:r>
-            <a:r>
-              <a:rPr lang="en-US" altLang="en-US" sz="2400" dirty="0">
-                <a:sym typeface="+mn-ea"/>
-                <a:hlinkClick r:id="rId3"/>
-              </a:rPr>
-              <a:t>         </a:t>
+              <a:t>https://www.youtube.com/watch?v=frwpuMEVA5k</a:t>
             </a:r>
             <a:endParaRPr lang="en-US" altLang="en-US" sz="2400" dirty="0">
               <a:sym typeface="+mn-ea"/>
@@ -5052,88 +4968,152 @@
             <a:pPr marL="635" indent="-635">
               <a:buNone/>
             </a:pPr>
-            <a:r>
+            <a:br>
               <a:rPr lang="en-US" altLang="en-US" sz="2400" dirty="0">
                 <a:sym typeface="+mn-ea"/>
               </a:rPr>
-              <a:t>Christian Kids</a:t>
-            </a:r>
-          </a:p>
-        </p:txBody>
-      </p:sp>
-      <p:sp>
-        <p:nvSpPr>
-          <p:cNvPr id="8" name="Text Box 7"/>
-          <p:cNvSpPr txBox="1"/>
-          <p:nvPr/>
-        </p:nvSpPr>
-        <p:spPr>
-          <a:xfrm>
-            <a:off x="6443980" y="3938270"/>
-            <a:ext cx="5399405" cy="2308324"/>
-          </a:xfrm>
-          <a:prstGeom prst="rect">
-            <a:avLst/>
-          </a:prstGeom>
-          <a:noFill/>
-        </p:spPr>
-        <p:txBody>
-          <a:bodyPr wrap="square" rtlCol="0" anchor="t">
-            <a:spAutoFit/>
-          </a:bodyPr>
-          <a:lstStyle/>
-          <a:p>
-            <a:pPr marL="0" indent="0" algn="l">
-              <a:buNone/>
-            </a:pPr>
-            <a:r>
-              <a:rPr lang="en-US" altLang="en-US" sz="2000" dirty="0">
-                <a:sym typeface="+mn-ea"/>
-              </a:rPr>
-              <a:t>2</a:t>
-            </a:r>
-            <a:r>
+            </a:br>
+            <a:br>
               <a:rPr lang="en-US" altLang="en-US" sz="2400" dirty="0">
                 <a:sym typeface="+mn-ea"/>
               </a:rPr>
-              <a:t>.</a:t>
-            </a:r>
-            <a:r>
-              <a:rPr lang="en-US" altLang="en-US" sz="2400" dirty="0">
-                <a:solidFill>
-                  <a:srgbClr val="FF0000"/>
-                </a:solidFill>
-                <a:sym typeface="+mn-ea"/>
-              </a:rPr>
-              <a:t> The Song of Moses </a:t>
-            </a:r>
-            <a:r>
-              <a:rPr lang="en-US" altLang="en-US" sz="2400" dirty="0">
-                <a:solidFill>
-                  <a:srgbClr val="00B050"/>
-                </a:solidFill>
-                <a:sym typeface="+mn-ea"/>
-                <a:hlinkClick r:id="rId4"/>
-              </a:rPr>
-              <a:t>https://www.youtube.com/watch?v=a-wWKL-7Mrg</a:t>
-            </a:r>
-            <a:endParaRPr lang="en-US" altLang="en-US" sz="2400" dirty="0">
-              <a:solidFill>
-                <a:srgbClr val="00B050"/>
-              </a:solidFill>
-              <a:sym typeface="+mn-ea"/>
-            </a:endParaRPr>
-          </a:p>
-          <a:p>
-            <a:pPr marL="0" indent="0" algn="l">
-              <a:buNone/>
-            </a:pPr>
+            </a:br>
             <a:r>
               <a:rPr lang="en-US" altLang="en-US" sz="2400" dirty="0">
                 <a:sym typeface="+mn-ea"/>
               </a:rPr>
-              <a:t>The Song of Moses Like You've Never Heard Before | Christian Worship Song/  World Wide Worship</a:t>
-            </a:r>
+              <a:t>2. Purim - New York Boys Choir - </a:t>
+            </a:r>
+            <a:r>
+              <a:rPr lang="en-US" altLang="en-US" sz="2400" dirty="0" err="1">
+                <a:sym typeface="+mn-ea"/>
+              </a:rPr>
+              <a:t>Hipil</a:t>
+            </a:r>
+            <a:r>
+              <a:rPr lang="en-US" altLang="en-US" sz="2400" dirty="0">
+                <a:sym typeface="+mn-ea"/>
+              </a:rPr>
+              <a:t> </a:t>
+            </a:r>
+            <a:r>
+              <a:rPr lang="en-US" altLang="en-US" sz="2400" dirty="0" err="1">
+                <a:sym typeface="+mn-ea"/>
+              </a:rPr>
+              <a:t>Pur</a:t>
+            </a:r>
+            <a:r>
+              <a:rPr lang="en-US" altLang="en-US" sz="2400" dirty="0">
+                <a:sym typeface="+mn-ea"/>
+              </a:rPr>
+              <a:t> </a:t>
+            </a:r>
+          </a:p>
+          <a:p>
+            <a:pPr marL="635" indent="-635">
+              <a:buNone/>
+            </a:pPr>
+            <a:r>
+              <a:rPr lang="en-US" altLang="en-US" sz="2400" dirty="0">
+                <a:sym typeface="+mn-ea"/>
+                <a:hlinkClick r:id="rId3">
+                  <a:extLst>
+                    <a:ext uri="{A12FA001-AC4F-418D-AE19-62706E023703}">
+                      <ahyp:hlinkClr xmlns:ahyp="http://schemas.microsoft.com/office/drawing/2018/hyperlinkcolor" val="tx"/>
+                    </a:ext>
+                  </a:extLst>
+                </a:hlinkClick>
+              </a:rPr>
+              <a:t>https://www.youtube.com/watch?v=7AMpwghyjwg&amp;list=RD7AMpwghyjwg&amp;start_radio=1</a:t>
+            </a:r>
+            <a:br>
+              <a:rPr lang="en-US" altLang="en-US" sz="2400" dirty="0">
+                <a:sym typeface="+mn-ea"/>
+              </a:rPr>
+            </a:br>
+            <a:br>
+              <a:rPr lang="en-US" altLang="en-US" sz="2400" dirty="0">
+                <a:sym typeface="+mn-ea"/>
+              </a:rPr>
+            </a:br>
+            <a:r>
+              <a:rPr lang="en-US" altLang="en-US" sz="2400" dirty="0">
+                <a:sym typeface="+mn-ea"/>
+              </a:rPr>
+              <a:t>https://</a:t>
+            </a:r>
+            <a:r>
+              <a:rPr lang="en-US" altLang="en-US" sz="2400" dirty="0" err="1">
+                <a:sym typeface="+mn-ea"/>
+              </a:rPr>
+              <a:t>www.youtube.com</a:t>
+            </a:r>
+            <a:r>
+              <a:rPr lang="en-US" altLang="en-US" sz="2400" dirty="0">
+                <a:sym typeface="+mn-ea"/>
+              </a:rPr>
+              <a:t>/</a:t>
+            </a:r>
+            <a:r>
+              <a:rPr lang="en-US" altLang="en-US" sz="2400" dirty="0" err="1">
+                <a:sym typeface="+mn-ea"/>
+              </a:rPr>
+              <a:t>watch?v</a:t>
+            </a:r>
+            <a:r>
+              <a:rPr lang="en-US" altLang="en-US" sz="2400" dirty="0">
+                <a:sym typeface="+mn-ea"/>
+              </a:rPr>
+              <a:t>=un8HXJwQzA8&amp;list=RDun8HXJwQzA8&amp;start_radio=1</a:t>
+            </a:r>
+          </a:p>
+          <a:p>
+            <a:pPr marL="635" indent="-635">
+              <a:buNone/>
+            </a:pPr>
+            <a:br>
+              <a:rPr lang="en-US" altLang="en-US" sz="2400" dirty="0">
+                <a:sym typeface="+mn-ea"/>
+              </a:rPr>
+            </a:br>
+            <a:r>
+              <a:rPr lang="en-US" altLang="en-US" sz="2400" dirty="0">
+                <a:sym typeface="+mn-ea"/>
+              </a:rPr>
+              <a:t>The Purim Song </a:t>
+            </a:r>
+            <a:br>
+              <a:rPr lang="en-US" altLang="en-US" sz="2400" dirty="0">
+                <a:sym typeface="+mn-ea"/>
+              </a:rPr>
+            </a:br>
+            <a:r>
+              <a:rPr lang="en-US" altLang="en-US" sz="2400" dirty="0">
+                <a:sym typeface="+mn-ea"/>
+                <a:hlinkClick r:id="rId4">
+                  <a:extLst>
+                    <a:ext uri="{A12FA001-AC4F-418D-AE19-62706E023703}">
+                      <ahyp:hlinkClr xmlns:ahyp="http://schemas.microsoft.com/office/drawing/2018/hyperlinkcolor" val="tx"/>
+                    </a:ext>
+                  </a:extLst>
+                </a:hlinkClick>
+              </a:rPr>
+              <a:t>https://www.youtube.com/watch?v=BDEnbL0FOUs&amp;list=RDBDEnbL0FOUs&amp;start_radio=1</a:t>
+            </a:r>
+            <a:r>
+              <a:rPr lang="en-US" altLang="en-US" sz="2400" dirty="0">
+                <a:sym typeface="+mn-ea"/>
+              </a:rPr>
+              <a:t> </a:t>
+            </a:r>
+          </a:p>
+          <a:p>
+            <a:pPr marL="635" indent="-635">
+              <a:buNone/>
+            </a:pPr>
+            <a:endParaRPr lang="en-US" altLang="en-US" sz="2400" dirty="0">
+              <a:sym typeface="+mn-ea"/>
+            </a:endParaRPr>
           </a:p>
         </p:txBody>
       </p:sp>
@@ -5225,7 +5205,7 @@
             <a:pPr algn="ctr"/>
             <a:r>
               <a:rPr lang="en-US" dirty="0"/>
-              <a:t>Esther</a:t>
+              <a:t>Who is Esther?</a:t>
             </a:r>
           </a:p>
         </p:txBody>
@@ -5321,6 +5301,10 @@
               <a:rPr lang="en-US" dirty="0"/>
               <a:t>Who is Esther?</a:t>
             </a:r>
+            <a:r>
+              <a:rPr lang="en-US" sz="2000" dirty="0"/>
+              <a:t> a hopeless child and in a hopeless generation.</a:t>
+            </a:r>
           </a:p>
         </p:txBody>
       </p:sp>
@@ -5340,14 +5324,14 @@
             <p:ph idx="1"/>
             <p:extLst>
               <p:ext uri="{D42A27DB-BD31-4B8C-83A1-F6EECF244321}">
-                <p14:modId xmlns:p14="http://schemas.microsoft.com/office/powerpoint/2010/main" val="4144713131"/>
+                <p14:modId xmlns:p14="http://schemas.microsoft.com/office/powerpoint/2010/main" val="401501164"/>
               </p:ext>
             </p:extLst>
           </p:nvPr>
         </p:nvGraphicFramePr>
         <p:xfrm>
-          <a:off x="609600" y="1174750"/>
-          <a:ext cx="10972797" cy="3200400"/>
+          <a:off x="433754" y="916842"/>
+          <a:ext cx="10972797" cy="4846320"/>
         </p:xfrm>
         <a:graphic>
           <a:graphicData uri="http://schemas.openxmlformats.org/drawingml/2006/table">
@@ -5709,7 +5693,68 @@
                           <a:latin typeface="Times New Roman" panose="02020603050405020304" pitchFamily="18" charset="0"/>
                           <a:cs typeface="Times New Roman" panose="02020603050405020304" pitchFamily="18" charset="0"/>
                         </a:rPr>
-                        <a:t>Raised by uncle Mordecai</a:t>
+                        <a:t>Raised by uncle Mordecai (estimated about 80 </a:t>
+                      </a:r>
+                      <a:r>
+                        <a:rPr lang="en-US" sz="2400" dirty="0" err="1">
+                          <a:latin typeface="Times New Roman" panose="02020603050405020304" pitchFamily="18" charset="0"/>
+                          <a:cs typeface="Times New Roman" panose="02020603050405020304" pitchFamily="18" charset="0"/>
+                        </a:rPr>
+                        <a:t>yrs</a:t>
+                      </a:r>
+                      <a:r>
+                        <a:rPr lang="en-US" sz="2400" dirty="0">
+                          <a:latin typeface="Times New Roman" panose="02020603050405020304" pitchFamily="18" charset="0"/>
+                          <a:cs typeface="Times New Roman" panose="02020603050405020304" pitchFamily="18" charset="0"/>
+                        </a:rPr>
+                        <a:t> old)</a:t>
+                      </a:r>
+                      <a:br>
+                        <a:rPr lang="en-US" sz="2400" dirty="0">
+                          <a:latin typeface="Times New Roman" panose="02020603050405020304" pitchFamily="18" charset="0"/>
+                          <a:cs typeface="Times New Roman" panose="02020603050405020304" pitchFamily="18" charset="0"/>
+                        </a:rPr>
+                      </a:br>
+                      <a:r>
+                        <a:rPr lang="en-US" sz="2400" dirty="0">
+                          <a:latin typeface="Times New Roman" panose="02020603050405020304" pitchFamily="18" charset="0"/>
+                          <a:cs typeface="Times New Roman" panose="02020603050405020304" pitchFamily="18" charset="0"/>
+                        </a:rPr>
+                        <a:t>"who had been carried into exile from Jerusalem by Nebuchadnezzar king of Babylon, among those taken captive with Jehoiachin king of Judah." (Est2:6 NIV)</a:t>
+                      </a:r>
+                      <a:br>
+                        <a:rPr lang="en-US" sz="2400" dirty="0">
+                          <a:latin typeface="Times New Roman" panose="02020603050405020304" pitchFamily="18" charset="0"/>
+                          <a:cs typeface="Times New Roman" panose="02020603050405020304" pitchFamily="18" charset="0"/>
+                        </a:rPr>
+                      </a:br>
+                      <a:r>
+                        <a:rPr lang="en-US" altLang="ja-JP" sz="1800" dirty="0">
+                          <a:latin typeface="Times New Roman" panose="02020603050405020304" pitchFamily="18" charset="0"/>
+                          <a:cs typeface="Times New Roman" panose="02020603050405020304" pitchFamily="18" charset="0"/>
+                        </a:rPr>
+                        <a:t>"</a:t>
+                      </a:r>
+                      <a:r>
+                        <a:rPr lang="ja-JP" altLang="en-US" sz="1800">
+                          <a:latin typeface="Times New Roman" panose="02020603050405020304" pitchFamily="18" charset="0"/>
+                          <a:cs typeface="Times New Roman" panose="02020603050405020304" pitchFamily="18" charset="0"/>
+                        </a:rPr>
+                        <a:t>从前巴比伦王尼布甲尼撒将犹大王耶哥尼雅（又名约雅斤）和百姓从耶路撒冷掳去、末底改也在其内。</a:t>
+                      </a:r>
+                      <a:r>
+                        <a:rPr lang="en-US" altLang="ja-JP" sz="1800" dirty="0">
+                          <a:latin typeface="Times New Roman" panose="02020603050405020304" pitchFamily="18" charset="0"/>
+                          <a:cs typeface="Times New Roman" panose="02020603050405020304" pitchFamily="18" charset="0"/>
+                        </a:rPr>
+                        <a:t>" (</a:t>
+                      </a:r>
+                      <a:r>
+                        <a:rPr lang="en-US" sz="1800" dirty="0">
+                          <a:latin typeface="Times New Roman" panose="02020603050405020304" pitchFamily="18" charset="0"/>
+                          <a:cs typeface="Times New Roman" panose="02020603050405020304" pitchFamily="18" charset="0"/>
+                        </a:rPr>
+                        <a:t>Est2:6 CUVS)</a:t>
                       </a:r>
                     </a:p>
                   </a:txBody>
@@ -5793,61 +5838,6 @@
           </a:graphicData>
         </a:graphic>
       </p:graphicFrame>
-      <p:sp>
-        <p:nvSpPr>
-          <p:cNvPr id="5" name="TextBox 4">
-            <a:extLst>
-              <a:ext uri="{FF2B5EF4-FFF2-40B4-BE49-F238E27FC236}">
-                <a16:creationId xmlns:a16="http://schemas.microsoft.com/office/drawing/2014/main" id="{11022AB8-8B6E-1212-14A5-59F86DDAF7B3}"/>
-              </a:ext>
-            </a:extLst>
-          </p:cNvPr>
-          <p:cNvSpPr txBox="1"/>
-          <p:nvPr/>
-        </p:nvSpPr>
-        <p:spPr>
-          <a:xfrm>
-            <a:off x="609600" y="4640513"/>
-            <a:ext cx="10972797" cy="1569660"/>
-          </a:xfrm>
-          <a:prstGeom prst="rect">
-            <a:avLst/>
-          </a:prstGeom>
-          <a:noFill/>
-        </p:spPr>
-        <p:txBody>
-          <a:bodyPr wrap="square" rtlCol="0">
-            <a:spAutoFit/>
-          </a:bodyPr>
-          <a:lstStyle/>
-          <a:p>
-            <a:r>
-              <a:rPr lang="en-US" sz="3200" dirty="0"/>
-              <a:t>Esther </a:t>
-            </a:r>
-          </a:p>
-          <a:p>
-            <a:pPr marL="457200" indent="-457200">
-              <a:buFont typeface="Arial" panose="020B0604020202020204" pitchFamily="34" charset="0"/>
-              <a:buChar char="•"/>
-            </a:pPr>
-            <a:r>
-              <a:rPr lang="en-US" sz="3200" dirty="0"/>
-              <a:t>is a hopeless child </a:t>
-            </a:r>
-          </a:p>
-          <a:p>
-            <a:pPr marL="457200" indent="-457200">
-              <a:buFont typeface="Arial" panose="020B0604020202020204" pitchFamily="34" charset="0"/>
-              <a:buChar char="•"/>
-            </a:pPr>
-            <a:r>
-              <a:rPr lang="en-US" sz="3200" dirty="0"/>
-              <a:t>belongs to a hopeless generation.</a:t>
-            </a:r>
-          </a:p>
-        </p:txBody>
-      </p:sp>
     </p:spTree>
     <p:extLst>
       <p:ext uri="{BB962C8B-B14F-4D97-AF65-F5344CB8AC3E}">
@@ -6099,7 +6089,13 @@
           <a:p>
             <a:r>
               <a:rPr lang="en-US" dirty="0"/>
-              <a:t>Have a heart of the mercy of God: adopt Esther as it is.</a:t>
+              <a:t>Have a heart of the mercy of the God: adopt Esther as it is.</a:t>
+            </a:r>
+          </a:p>
+          <a:p>
+            <a:r>
+              <a:rPr lang="en-US" dirty="0"/>
+              <a:t>No complain to take over the parenting duty.</a:t>
             </a:r>
           </a:p>
           <a:p>
@@ -6109,10 +6105,7 @@
             </a:r>
           </a:p>
           <a:p>
-            <a:r>
-              <a:rPr lang="en-US" dirty="0"/>
-              <a:t>No complain to take over the parenting duty.</a:t>
-            </a:r>
+            <a:endParaRPr lang="en-US" dirty="0"/>
           </a:p>
           <a:p>
             <a:pPr marL="0" indent="0">
@@ -6486,9 +6479,34 @@
           <a:p>
             <a:r>
               <a:rPr lang="en-US" altLang="ja-JP" dirty="0"/>
-              <a:t>Esther 2:21–23</a:t>
-            </a:r>
-            <a:endParaRPr lang="en-US" dirty="0"/>
+              <a:t>Esther 2:21–23.</a:t>
+            </a:r>
+          </a:p>
+          <a:p>
+            <a:r>
+              <a:rPr lang="en-US" dirty="0"/>
+              <a:t>"But Mordecai found out about the plot and told Queen Esther, who in turn reported it to the king, giving credit to Mordecai." (Est2:22 NIV)</a:t>
+            </a:r>
+            <a:r>
+              <a:rPr lang="ja-JP" altLang="en-US"/>
+              <a:t> </a:t>
+            </a:r>
+            <a:r>
+              <a:rPr lang="en-US" altLang="ja-JP" dirty="0"/>
+              <a:t>"</a:t>
+            </a:r>
+            <a:r>
+              <a:rPr lang="ja-JP" altLang="en-US"/>
+              <a:t>末底改知道了、就告诉王后以斯帖．以斯帖奉末底改的名、报告于王．</a:t>
+            </a:r>
+            <a:r>
+              <a:rPr lang="en-US" altLang="ja-JP" dirty="0"/>
+              <a:t>" (</a:t>
+            </a:r>
+            <a:r>
+              <a:rPr lang="en-US" dirty="0"/>
+              <a:t>Est2:22 CUVS)</a:t>
+            </a:r>
           </a:p>
           <a:p>
             <a:endParaRPr lang="en-US" dirty="0"/>

</xml_diff>